<commit_message>
docs: guardar los diagramas con PowerPoint
</commit_message>
<xml_diff>
--- a/docs/Diagramas - Actividad 2.pptx
+++ b/docs/Diagramas - Actividad 2.pptx
@@ -5,11 +5,11 @@
     <p:sldMasterId id="2147483648" r:id="rId1"/>
   </p:sldMasterIdLst>
   <p:sldIdLst>
-    <p:sldId id="256" r:id="rId7"/>
-    <p:sldId id="257" r:id="rId8"/>
-    <p:sldId id="258" r:id="rId9"/>
+    <p:sldId id="256" r:id="rId2"/>
+    <p:sldId id="257" r:id="rId3"/>
+    <p:sldId id="258" r:id="rId4"/>
   </p:sldIdLst>
-  <p:sldSz cx="12191695" cy="6858000" type="screen4x3"/>
+  <p:sldSz cx="12192000" cy="6858000"/>
   <p:notesSz cx="6858000" cy="9144000"/>
   <p:defaultTextStyle>
     <a:defPPr>
@@ -106,6 +106,22 @@
       </a:defRPr>
     </a:lvl9pPr>
   </p:defaultTextStyle>
+  <p:extLst>
+    <p:ext uri="{EFAFB233-063F-42B5-8137-9DF3F51BA10A}">
+      <p15:sldGuideLst xmlns:p15="http://schemas.microsoft.com/office/powerpoint/2012/main">
+        <p15:guide id="1" orient="horz" pos="2160">
+          <p15:clr>
+            <a:srgbClr val="A4A3A4"/>
+          </p15:clr>
+        </p15:guide>
+        <p15:guide id="2" pos="2880">
+          <p15:clr>
+            <a:srgbClr val="A4A3A4"/>
+          </p15:clr>
+        </p15:guide>
+      </p15:sldGuideLst>
+    </p:ext>
+  </p:extLst>
 </p:presentation>
 </file>
 
@@ -147,10 +163,9 @@
           <a:lstStyle/>
           <a:p>
             <a:r>
-              <a:rPr lang="en-US" smtClean="0"/>
+              <a:rPr lang="en-US"/>
               <a:t>Click to edit Master title style</a:t>
             </a:r>
-            <a:endParaRPr lang="en-US"/>
           </a:p>
         </p:txBody>
       </p:sp>
@@ -266,10 +281,9 @@
           </a:lstStyle>
           <a:p>
             <a:r>
-              <a:rPr lang="en-US" smtClean="0"/>
+              <a:rPr lang="en-US"/>
               <a:t>Click to edit Master subtitle style</a:t>
             </a:r>
-            <a:endParaRPr lang="en-US"/>
           </a:p>
         </p:txBody>
       </p:sp>
@@ -290,7 +304,7 @@
           <a:p>
             <a:fld id="{5BCAD085-E8A6-8845-BD4E-CB4CCA059FC4}" type="datetimeFigureOut">
               <a:rPr lang="en-US" smtClean="0"/>
-              <a:t>1/27/13</a:t>
+              <a:t>10/28/2026</a:t>
             </a:fld>
             <a:endParaRPr lang="en-US"/>
           </a:p>
@@ -332,7 +346,7 @@
           <a:p>
             <a:fld id="{C1FF6DA9-008F-8B48-92A6-B652298478BF}" type="slidenum">
               <a:rPr lang="en-US" smtClean="0"/>
-              <a:t>‹#›</a:t>
+              <a:t>‹Nº›</a:t>
             </a:fld>
             <a:endParaRPr lang="en-US"/>
           </a:p>
@@ -384,10 +398,9 @@
           <a:lstStyle/>
           <a:p>
             <a:r>
-              <a:rPr lang="en-US" smtClean="0"/>
+              <a:rPr lang="en-US"/>
               <a:t>Click to edit Master title style</a:t>
             </a:r>
-            <a:endParaRPr lang="en-US"/>
           </a:p>
         </p:txBody>
       </p:sp>
@@ -408,38 +421,37 @@
           <a:p>
             <a:pPr lvl="0"/>
             <a:r>
-              <a:rPr lang="en-US" smtClean="0"/>
+              <a:rPr lang="en-US"/>
               <a:t>Click to edit Master text styles</a:t>
             </a:r>
           </a:p>
           <a:p>
             <a:pPr lvl="1"/>
             <a:r>
-              <a:rPr lang="en-US" smtClean="0"/>
+              <a:rPr lang="en-US"/>
               <a:t>Second level</a:t>
             </a:r>
           </a:p>
           <a:p>
             <a:pPr lvl="2"/>
             <a:r>
-              <a:rPr lang="en-US" smtClean="0"/>
+              <a:rPr lang="en-US"/>
               <a:t>Third level</a:t>
             </a:r>
           </a:p>
           <a:p>
             <a:pPr lvl="3"/>
             <a:r>
-              <a:rPr lang="en-US" smtClean="0"/>
+              <a:rPr lang="en-US"/>
               <a:t>Fourth level</a:t>
             </a:r>
           </a:p>
           <a:p>
             <a:pPr lvl="4"/>
             <a:r>
-              <a:rPr lang="en-US" smtClean="0"/>
+              <a:rPr lang="en-US"/>
               <a:t>Fifth level</a:t>
             </a:r>
-            <a:endParaRPr lang="en-US"/>
           </a:p>
         </p:txBody>
       </p:sp>
@@ -460,7 +472,7 @@
           <a:p>
             <a:fld id="{5BCAD085-E8A6-8845-BD4E-CB4CCA059FC4}" type="datetimeFigureOut">
               <a:rPr lang="en-US" smtClean="0"/>
-              <a:t>1/27/13</a:t>
+              <a:t>10/28/2026</a:t>
             </a:fld>
             <a:endParaRPr lang="en-US"/>
           </a:p>
@@ -502,7 +514,7 @@
           <a:p>
             <a:fld id="{C1FF6DA9-008F-8B48-92A6-B652298478BF}" type="slidenum">
               <a:rPr lang="en-US" smtClean="0"/>
-              <a:t>‹#›</a:t>
+              <a:t>‹Nº›</a:t>
             </a:fld>
             <a:endParaRPr lang="en-US"/>
           </a:p>
@@ -559,10 +571,9 @@
           <a:lstStyle/>
           <a:p>
             <a:r>
-              <a:rPr lang="en-US" smtClean="0"/>
+              <a:rPr lang="en-US"/>
               <a:t>Click to edit Master title style</a:t>
             </a:r>
-            <a:endParaRPr lang="en-US"/>
           </a:p>
         </p:txBody>
       </p:sp>
@@ -588,38 +599,37 @@
           <a:p>
             <a:pPr lvl="0"/>
             <a:r>
-              <a:rPr lang="en-US" smtClean="0"/>
+              <a:rPr lang="en-US"/>
               <a:t>Click to edit Master text styles</a:t>
             </a:r>
           </a:p>
           <a:p>
             <a:pPr lvl="1"/>
             <a:r>
-              <a:rPr lang="en-US" smtClean="0"/>
+              <a:rPr lang="en-US"/>
               <a:t>Second level</a:t>
             </a:r>
           </a:p>
           <a:p>
             <a:pPr lvl="2"/>
             <a:r>
-              <a:rPr lang="en-US" smtClean="0"/>
+              <a:rPr lang="en-US"/>
               <a:t>Third level</a:t>
             </a:r>
           </a:p>
           <a:p>
             <a:pPr lvl="3"/>
             <a:r>
-              <a:rPr lang="en-US" smtClean="0"/>
+              <a:rPr lang="en-US"/>
               <a:t>Fourth level</a:t>
             </a:r>
           </a:p>
           <a:p>
             <a:pPr lvl="4"/>
             <a:r>
-              <a:rPr lang="en-US" smtClean="0"/>
+              <a:rPr lang="en-US"/>
               <a:t>Fifth level</a:t>
             </a:r>
-            <a:endParaRPr lang="en-US"/>
           </a:p>
         </p:txBody>
       </p:sp>
@@ -640,7 +650,7 @@
           <a:p>
             <a:fld id="{5BCAD085-E8A6-8845-BD4E-CB4CCA059FC4}" type="datetimeFigureOut">
               <a:rPr lang="en-US" smtClean="0"/>
-              <a:t>1/27/13</a:t>
+              <a:t>10/28/2026</a:t>
             </a:fld>
             <a:endParaRPr lang="en-US"/>
           </a:p>
@@ -682,7 +692,7 @@
           <a:p>
             <a:fld id="{C1FF6DA9-008F-8B48-92A6-B652298478BF}" type="slidenum">
               <a:rPr lang="en-US" smtClean="0"/>
-              <a:t>‹#›</a:t>
+              <a:t>‹Nº›</a:t>
             </a:fld>
             <a:endParaRPr lang="en-US"/>
           </a:p>
@@ -734,10 +744,9 @@
           <a:lstStyle/>
           <a:p>
             <a:r>
-              <a:rPr lang="en-US" smtClean="0"/>
+              <a:rPr lang="en-US"/>
               <a:t>Click to edit Master title style</a:t>
             </a:r>
-            <a:endParaRPr lang="en-US"/>
           </a:p>
         </p:txBody>
       </p:sp>
@@ -758,38 +767,37 @@
           <a:p>
             <a:pPr lvl="0"/>
             <a:r>
-              <a:rPr lang="en-US" smtClean="0"/>
+              <a:rPr lang="en-US"/>
               <a:t>Click to edit Master text styles</a:t>
             </a:r>
           </a:p>
           <a:p>
             <a:pPr lvl="1"/>
             <a:r>
-              <a:rPr lang="en-US" smtClean="0"/>
+              <a:rPr lang="en-US"/>
               <a:t>Second level</a:t>
             </a:r>
           </a:p>
           <a:p>
             <a:pPr lvl="2"/>
             <a:r>
-              <a:rPr lang="en-US" smtClean="0"/>
+              <a:rPr lang="en-US"/>
               <a:t>Third level</a:t>
             </a:r>
           </a:p>
           <a:p>
             <a:pPr lvl="3"/>
             <a:r>
-              <a:rPr lang="en-US" smtClean="0"/>
+              <a:rPr lang="en-US"/>
               <a:t>Fourth level</a:t>
             </a:r>
           </a:p>
           <a:p>
             <a:pPr lvl="4"/>
             <a:r>
-              <a:rPr lang="en-US" smtClean="0"/>
+              <a:rPr lang="en-US"/>
               <a:t>Fifth level</a:t>
             </a:r>
-            <a:endParaRPr lang="en-US"/>
           </a:p>
         </p:txBody>
       </p:sp>
@@ -810,7 +818,7 @@
           <a:p>
             <a:fld id="{5BCAD085-E8A6-8845-BD4E-CB4CCA059FC4}" type="datetimeFigureOut">
               <a:rPr lang="en-US" smtClean="0"/>
-              <a:t>1/27/13</a:t>
+              <a:t>10/28/2026</a:t>
             </a:fld>
             <a:endParaRPr lang="en-US"/>
           </a:p>
@@ -852,7 +860,7 @@
           <a:p>
             <a:fld id="{C1FF6DA9-008F-8B48-92A6-B652298478BF}" type="slidenum">
               <a:rPr lang="en-US" smtClean="0"/>
-              <a:t>‹#›</a:t>
+              <a:t>‹Nº›</a:t>
             </a:fld>
             <a:endParaRPr lang="en-US"/>
           </a:p>
@@ -913,10 +921,9 @@
           </a:lstStyle>
           <a:p>
             <a:r>
-              <a:rPr lang="en-US" smtClean="0"/>
+              <a:rPr lang="en-US"/>
               <a:t>Click to edit Master title style</a:t>
             </a:r>
-            <a:endParaRPr lang="en-US"/>
           </a:p>
         </p:txBody>
       </p:sp>
@@ -1033,7 +1040,7 @@
           <a:p>
             <a:pPr lvl="0"/>
             <a:r>
-              <a:rPr lang="en-US" smtClean="0"/>
+              <a:rPr lang="en-US"/>
               <a:t>Click to edit Master text styles</a:t>
             </a:r>
           </a:p>
@@ -1056,7 +1063,7 @@
           <a:p>
             <a:fld id="{5BCAD085-E8A6-8845-BD4E-CB4CCA059FC4}" type="datetimeFigureOut">
               <a:rPr lang="en-US" smtClean="0"/>
-              <a:t>1/27/13</a:t>
+              <a:t>10/28/2026</a:t>
             </a:fld>
             <a:endParaRPr lang="en-US"/>
           </a:p>
@@ -1098,7 +1105,7 @@
           <a:p>
             <a:fld id="{C1FF6DA9-008F-8B48-92A6-B652298478BF}" type="slidenum">
               <a:rPr lang="en-US" smtClean="0"/>
-              <a:t>‹#›</a:t>
+              <a:t>‹Nº›</a:t>
             </a:fld>
             <a:endParaRPr lang="en-US"/>
           </a:p>
@@ -1150,10 +1157,9 @@
           <a:lstStyle/>
           <a:p>
             <a:r>
-              <a:rPr lang="en-US" smtClean="0"/>
+              <a:rPr lang="en-US"/>
               <a:t>Click to edit Master title style</a:t>
             </a:r>
-            <a:endParaRPr lang="en-US"/>
           </a:p>
         </p:txBody>
       </p:sp>
@@ -1207,38 +1213,37 @@
           <a:p>
             <a:pPr lvl="0"/>
             <a:r>
-              <a:rPr lang="en-US" smtClean="0"/>
+              <a:rPr lang="en-US"/>
               <a:t>Click to edit Master text styles</a:t>
             </a:r>
           </a:p>
           <a:p>
             <a:pPr lvl="1"/>
             <a:r>
-              <a:rPr lang="en-US" smtClean="0"/>
+              <a:rPr lang="en-US"/>
               <a:t>Second level</a:t>
             </a:r>
           </a:p>
           <a:p>
             <a:pPr lvl="2"/>
             <a:r>
-              <a:rPr lang="en-US" smtClean="0"/>
+              <a:rPr lang="en-US"/>
               <a:t>Third level</a:t>
             </a:r>
           </a:p>
           <a:p>
             <a:pPr lvl="3"/>
             <a:r>
-              <a:rPr lang="en-US" smtClean="0"/>
+              <a:rPr lang="en-US"/>
               <a:t>Fourth level</a:t>
             </a:r>
           </a:p>
           <a:p>
             <a:pPr lvl="4"/>
             <a:r>
-              <a:rPr lang="en-US" smtClean="0"/>
+              <a:rPr lang="en-US"/>
               <a:t>Fifth level</a:t>
             </a:r>
-            <a:endParaRPr lang="en-US"/>
           </a:p>
         </p:txBody>
       </p:sp>
@@ -1292,38 +1297,37 @@
           <a:p>
             <a:pPr lvl="0"/>
             <a:r>
-              <a:rPr lang="en-US" smtClean="0"/>
+              <a:rPr lang="en-US"/>
               <a:t>Click to edit Master text styles</a:t>
             </a:r>
           </a:p>
           <a:p>
             <a:pPr lvl="1"/>
             <a:r>
-              <a:rPr lang="en-US" smtClean="0"/>
+              <a:rPr lang="en-US"/>
               <a:t>Second level</a:t>
             </a:r>
           </a:p>
           <a:p>
             <a:pPr lvl="2"/>
             <a:r>
-              <a:rPr lang="en-US" smtClean="0"/>
+              <a:rPr lang="en-US"/>
               <a:t>Third level</a:t>
             </a:r>
           </a:p>
           <a:p>
             <a:pPr lvl="3"/>
             <a:r>
-              <a:rPr lang="en-US" smtClean="0"/>
+              <a:rPr lang="en-US"/>
               <a:t>Fourth level</a:t>
             </a:r>
           </a:p>
           <a:p>
             <a:pPr lvl="4"/>
             <a:r>
-              <a:rPr lang="en-US" smtClean="0"/>
+              <a:rPr lang="en-US"/>
               <a:t>Fifth level</a:t>
             </a:r>
-            <a:endParaRPr lang="en-US"/>
           </a:p>
         </p:txBody>
       </p:sp>
@@ -1344,7 +1348,7 @@
           <a:p>
             <a:fld id="{5BCAD085-E8A6-8845-BD4E-CB4CCA059FC4}" type="datetimeFigureOut">
               <a:rPr lang="en-US" smtClean="0"/>
-              <a:t>1/27/13</a:t>
+              <a:t>10/28/2026</a:t>
             </a:fld>
             <a:endParaRPr lang="en-US"/>
           </a:p>
@@ -1386,7 +1390,7 @@
           <a:p>
             <a:fld id="{C1FF6DA9-008F-8B48-92A6-B652298478BF}" type="slidenum">
               <a:rPr lang="en-US" smtClean="0"/>
-              <a:t>‹#›</a:t>
+              <a:t>‹Nº›</a:t>
             </a:fld>
             <a:endParaRPr lang="en-US"/>
           </a:p>
@@ -1442,10 +1446,9 @@
           </a:lstStyle>
           <a:p>
             <a:r>
-              <a:rPr lang="en-US" smtClean="0"/>
+              <a:rPr lang="en-US"/>
               <a:t>Click to edit Master title style</a:t>
             </a:r>
-            <a:endParaRPr lang="en-US"/>
           </a:p>
         </p:txBody>
       </p:sp>
@@ -1508,7 +1511,7 @@
           <a:p>
             <a:pPr lvl="0"/>
             <a:r>
-              <a:rPr lang="en-US" smtClean="0"/>
+              <a:rPr lang="en-US"/>
               <a:t>Click to edit Master text styles</a:t>
             </a:r>
           </a:p>
@@ -1564,38 +1567,37 @@
           <a:p>
             <a:pPr lvl="0"/>
             <a:r>
-              <a:rPr lang="en-US" smtClean="0"/>
+              <a:rPr lang="en-US"/>
               <a:t>Click to edit Master text styles</a:t>
             </a:r>
           </a:p>
           <a:p>
             <a:pPr lvl="1"/>
             <a:r>
-              <a:rPr lang="en-US" smtClean="0"/>
+              <a:rPr lang="en-US"/>
               <a:t>Second level</a:t>
             </a:r>
           </a:p>
           <a:p>
             <a:pPr lvl="2"/>
             <a:r>
-              <a:rPr lang="en-US" smtClean="0"/>
+              <a:rPr lang="en-US"/>
               <a:t>Third level</a:t>
             </a:r>
           </a:p>
           <a:p>
             <a:pPr lvl="3"/>
             <a:r>
-              <a:rPr lang="en-US" smtClean="0"/>
+              <a:rPr lang="en-US"/>
               <a:t>Fourth level</a:t>
             </a:r>
           </a:p>
           <a:p>
             <a:pPr lvl="4"/>
             <a:r>
-              <a:rPr lang="en-US" smtClean="0"/>
+              <a:rPr lang="en-US"/>
               <a:t>Fifth level</a:t>
             </a:r>
-            <a:endParaRPr lang="en-US"/>
           </a:p>
         </p:txBody>
       </p:sp>
@@ -1658,7 +1660,7 @@
           <a:p>
             <a:pPr lvl="0"/>
             <a:r>
-              <a:rPr lang="en-US" smtClean="0"/>
+              <a:rPr lang="en-US"/>
               <a:t>Click to edit Master text styles</a:t>
             </a:r>
           </a:p>
@@ -1714,38 +1716,37 @@
           <a:p>
             <a:pPr lvl="0"/>
             <a:r>
-              <a:rPr lang="en-US" smtClean="0"/>
+              <a:rPr lang="en-US"/>
               <a:t>Click to edit Master text styles</a:t>
             </a:r>
           </a:p>
           <a:p>
             <a:pPr lvl="1"/>
             <a:r>
-              <a:rPr lang="en-US" smtClean="0"/>
+              <a:rPr lang="en-US"/>
               <a:t>Second level</a:t>
             </a:r>
           </a:p>
           <a:p>
             <a:pPr lvl="2"/>
             <a:r>
-              <a:rPr lang="en-US" smtClean="0"/>
+              <a:rPr lang="en-US"/>
               <a:t>Third level</a:t>
             </a:r>
           </a:p>
           <a:p>
             <a:pPr lvl="3"/>
             <a:r>
-              <a:rPr lang="en-US" smtClean="0"/>
+              <a:rPr lang="en-US"/>
               <a:t>Fourth level</a:t>
             </a:r>
           </a:p>
           <a:p>
             <a:pPr lvl="4"/>
             <a:r>
-              <a:rPr lang="en-US" smtClean="0"/>
+              <a:rPr lang="en-US"/>
               <a:t>Fifth level</a:t>
             </a:r>
-            <a:endParaRPr lang="en-US"/>
           </a:p>
         </p:txBody>
       </p:sp>
@@ -1766,7 +1767,7 @@
           <a:p>
             <a:fld id="{5BCAD085-E8A6-8845-BD4E-CB4CCA059FC4}" type="datetimeFigureOut">
               <a:rPr lang="en-US" smtClean="0"/>
-              <a:t>1/27/13</a:t>
+              <a:t>10/28/2026</a:t>
             </a:fld>
             <a:endParaRPr lang="en-US"/>
           </a:p>
@@ -1808,7 +1809,7 @@
           <a:p>
             <a:fld id="{C1FF6DA9-008F-8B48-92A6-B652298478BF}" type="slidenum">
               <a:rPr lang="en-US" smtClean="0"/>
-              <a:t>‹#›</a:t>
+              <a:t>‹Nº›</a:t>
             </a:fld>
             <a:endParaRPr lang="en-US"/>
           </a:p>
@@ -1860,10 +1861,9 @@
           <a:lstStyle/>
           <a:p>
             <a:r>
-              <a:rPr lang="en-US" smtClean="0"/>
+              <a:rPr lang="en-US"/>
               <a:t>Click to edit Master title style</a:t>
             </a:r>
-            <a:endParaRPr lang="en-US"/>
           </a:p>
         </p:txBody>
       </p:sp>
@@ -1884,7 +1884,7 @@
           <a:p>
             <a:fld id="{5BCAD085-E8A6-8845-BD4E-CB4CCA059FC4}" type="datetimeFigureOut">
               <a:rPr lang="en-US" smtClean="0"/>
-              <a:t>1/27/13</a:t>
+              <a:t>10/28/2026</a:t>
             </a:fld>
             <a:endParaRPr lang="en-US"/>
           </a:p>
@@ -1926,7 +1926,7 @@
           <a:p>
             <a:fld id="{C1FF6DA9-008F-8B48-92A6-B652298478BF}" type="slidenum">
               <a:rPr lang="en-US" smtClean="0"/>
-              <a:t>‹#›</a:t>
+              <a:t>‹Nº›</a:t>
             </a:fld>
             <a:endParaRPr lang="en-US"/>
           </a:p>
@@ -1979,7 +1979,7 @@
           <a:p>
             <a:fld id="{5BCAD085-E8A6-8845-BD4E-CB4CCA059FC4}" type="datetimeFigureOut">
               <a:rPr lang="en-US" smtClean="0"/>
-              <a:t>1/27/13</a:t>
+              <a:t>10/28/2026</a:t>
             </a:fld>
             <a:endParaRPr lang="en-US"/>
           </a:p>
@@ -2021,7 +2021,7 @@
           <a:p>
             <a:fld id="{C1FF6DA9-008F-8B48-92A6-B652298478BF}" type="slidenum">
               <a:rPr lang="en-US" smtClean="0"/>
-              <a:t>‹#›</a:t>
+              <a:t>‹Nº›</a:t>
             </a:fld>
             <a:endParaRPr lang="en-US"/>
           </a:p>
@@ -2082,10 +2082,9 @@
           </a:lstStyle>
           <a:p>
             <a:r>
-              <a:rPr lang="en-US" smtClean="0"/>
+              <a:rPr lang="en-US"/>
               <a:t>Click to edit Master title style</a:t>
             </a:r>
-            <a:endParaRPr lang="en-US"/>
           </a:p>
         </p:txBody>
       </p:sp>
@@ -2139,38 +2138,37 @@
           <a:p>
             <a:pPr lvl="0"/>
             <a:r>
-              <a:rPr lang="en-US" smtClean="0"/>
+              <a:rPr lang="en-US"/>
               <a:t>Click to edit Master text styles</a:t>
             </a:r>
           </a:p>
           <a:p>
             <a:pPr lvl="1"/>
             <a:r>
-              <a:rPr lang="en-US" smtClean="0"/>
+              <a:rPr lang="en-US"/>
               <a:t>Second level</a:t>
             </a:r>
           </a:p>
           <a:p>
             <a:pPr lvl="2"/>
             <a:r>
-              <a:rPr lang="en-US" smtClean="0"/>
+              <a:rPr lang="en-US"/>
               <a:t>Third level</a:t>
             </a:r>
           </a:p>
           <a:p>
             <a:pPr lvl="3"/>
             <a:r>
-              <a:rPr lang="en-US" smtClean="0"/>
+              <a:rPr lang="en-US"/>
               <a:t>Fourth level</a:t>
             </a:r>
           </a:p>
           <a:p>
             <a:pPr lvl="4"/>
             <a:r>
-              <a:rPr lang="en-US" smtClean="0"/>
+              <a:rPr lang="en-US"/>
               <a:t>Fifth level</a:t>
             </a:r>
-            <a:endParaRPr lang="en-US"/>
           </a:p>
         </p:txBody>
       </p:sp>
@@ -2233,7 +2231,7 @@
           <a:p>
             <a:pPr lvl="0"/>
             <a:r>
-              <a:rPr lang="en-US" smtClean="0"/>
+              <a:rPr lang="en-US"/>
               <a:t>Click to edit Master text styles</a:t>
             </a:r>
           </a:p>
@@ -2256,7 +2254,7 @@
           <a:p>
             <a:fld id="{5BCAD085-E8A6-8845-BD4E-CB4CCA059FC4}" type="datetimeFigureOut">
               <a:rPr lang="en-US" smtClean="0"/>
-              <a:t>1/27/13</a:t>
+              <a:t>10/28/2026</a:t>
             </a:fld>
             <a:endParaRPr lang="en-US"/>
           </a:p>
@@ -2298,7 +2296,7 @@
           <a:p>
             <a:fld id="{C1FF6DA9-008F-8B48-92A6-B652298478BF}" type="slidenum">
               <a:rPr lang="en-US" smtClean="0"/>
-              <a:t>‹#›</a:t>
+              <a:t>‹Nº›</a:t>
             </a:fld>
             <a:endParaRPr lang="en-US"/>
           </a:p>
@@ -2359,10 +2357,9 @@
           </a:lstStyle>
           <a:p>
             <a:r>
-              <a:rPr lang="en-US" smtClean="0"/>
+              <a:rPr lang="en-US"/>
               <a:t>Click to edit Master title style</a:t>
             </a:r>
-            <a:endParaRPr lang="en-US"/>
           </a:p>
         </p:txBody>
       </p:sp>
@@ -2486,7 +2483,7 @@
           <a:p>
             <a:pPr lvl="0"/>
             <a:r>
-              <a:rPr lang="en-US" smtClean="0"/>
+              <a:rPr lang="en-US"/>
               <a:t>Click to edit Master text styles</a:t>
             </a:r>
           </a:p>
@@ -2509,7 +2506,7 @@
           <a:p>
             <a:fld id="{5BCAD085-E8A6-8845-BD4E-CB4CCA059FC4}" type="datetimeFigureOut">
               <a:rPr lang="en-US" smtClean="0"/>
-              <a:t>1/27/13</a:t>
+              <a:t>10/28/2026</a:t>
             </a:fld>
             <a:endParaRPr lang="en-US"/>
           </a:p>
@@ -2551,7 +2548,7 @@
           <a:p>
             <a:fld id="{C1FF6DA9-008F-8B48-92A6-B652298478BF}" type="slidenum">
               <a:rPr lang="en-US" smtClean="0"/>
-              <a:t>‹#›</a:t>
+              <a:t>‹Nº›</a:t>
             </a:fld>
             <a:endParaRPr lang="en-US"/>
           </a:p>
@@ -2618,10 +2615,9 @@
           <a:lstStyle/>
           <a:p>
             <a:r>
-              <a:rPr lang="en-US" smtClean="0"/>
+              <a:rPr lang="en-US"/>
               <a:t>Click to edit Master title style</a:t>
             </a:r>
-            <a:endParaRPr lang="en-US"/>
           </a:p>
         </p:txBody>
       </p:sp>
@@ -2652,38 +2648,37 @@
           <a:p>
             <a:pPr lvl="0"/>
             <a:r>
-              <a:rPr lang="en-US" smtClean="0"/>
+              <a:rPr lang="en-US"/>
               <a:t>Click to edit Master text styles</a:t>
             </a:r>
           </a:p>
           <a:p>
             <a:pPr lvl="1"/>
             <a:r>
-              <a:rPr lang="en-US" smtClean="0"/>
+              <a:rPr lang="en-US"/>
               <a:t>Second level</a:t>
             </a:r>
           </a:p>
           <a:p>
             <a:pPr lvl="2"/>
             <a:r>
-              <a:rPr lang="en-US" smtClean="0"/>
+              <a:rPr lang="en-US"/>
               <a:t>Third level</a:t>
             </a:r>
           </a:p>
           <a:p>
             <a:pPr lvl="3"/>
             <a:r>
-              <a:rPr lang="en-US" smtClean="0"/>
+              <a:rPr lang="en-US"/>
               <a:t>Fourth level</a:t>
             </a:r>
           </a:p>
           <a:p>
             <a:pPr lvl="4"/>
             <a:r>
-              <a:rPr lang="en-US" smtClean="0"/>
+              <a:rPr lang="en-US"/>
               <a:t>Fifth level</a:t>
             </a:r>
-            <a:endParaRPr lang="en-US"/>
           </a:p>
         </p:txBody>
       </p:sp>
@@ -2722,7 +2717,7 @@
           <a:p>
             <a:fld id="{5BCAD085-E8A6-8845-BD4E-CB4CCA059FC4}" type="datetimeFigureOut">
               <a:rPr lang="en-US" smtClean="0"/>
-              <a:t>1/27/13</a:t>
+              <a:t>10/28/2026</a:t>
             </a:fld>
             <a:endParaRPr lang="en-US"/>
           </a:p>
@@ -2800,7 +2795,7 @@
           <a:p>
             <a:fld id="{C1FF6DA9-008F-8B48-92A6-B652298478BF}" type="slidenum">
               <a:rPr lang="en-US" smtClean="0"/>
-              <a:t>‹#›</a:t>
+              <a:t>‹Nº›</a:t>
             </a:fld>
             <a:endParaRPr lang="en-US"/>
           </a:p>
@@ -3081,7 +3076,7 @@
 </file>
 
 <file path=ppt/slides/slide1.xml><?xml version="1.0" encoding="utf-8"?>
-<p:sld xmlns:a="http://schemas.openxmlformats.org/drawingml/2006/main" xmlns:p="http://schemas.openxmlformats.org/presentationml/2006/main" xmlns:r="http://schemas.openxmlformats.org/officeDocument/2006/relationships">
+<p:sld xmlns:a="http://schemas.openxmlformats.org/drawingml/2006/main" xmlns:r="http://schemas.openxmlformats.org/officeDocument/2006/relationships" xmlns:p="http://schemas.openxmlformats.org/presentationml/2006/main">
   <p:cSld>
     <p:spTree>
       <p:nvGrpSpPr>
@@ -3089,7 +3084,14 @@
         <p:cNvGrpSpPr/>
         <p:nvPr/>
       </p:nvGrpSpPr>
-      <p:grpSpPr/>
+      <p:grpSpPr>
+        <a:xfrm>
+          <a:off x="0" y="0"/>
+          <a:ext cx="0" cy="0"/>
+          <a:chOff x="0" y="0"/>
+          <a:chExt cx="0" cy="0"/>
+        </a:xfrm>
+      </p:grpSpPr>
       <p:sp>
         <p:nvSpPr>
           <p:cNvPr id="2" name="TextBox 1"/>
@@ -3176,7 +3178,7 @@
           </a:fontRef>
         </p:style>
         <p:txBody>
-          <a:bodyPr rtlCol="0" anchor="t" wrap="square" lIns="109728" rIns="109728" tIns="73152"/>
+          <a:bodyPr wrap="square" lIns="109728" tIns="73152" rIns="109728" rtlCol="0" anchor="t"/>
           <a:lstStyle/>
           <a:p>
             <a:pPr algn="l"/>
@@ -3281,7 +3283,7 @@
           </a:fontRef>
         </p:style>
         <p:txBody>
-          <a:bodyPr rtlCol="0" anchor="t" wrap="square" lIns="109728" rIns="109728" tIns="73152"/>
+          <a:bodyPr wrap="square" lIns="109728" tIns="73152" rIns="109728" rtlCol="0" anchor="t"/>
           <a:lstStyle/>
           <a:p>
             <a:pPr algn="l"/>
@@ -3362,7 +3364,7 @@
           </a:fontRef>
         </p:style>
         <p:txBody>
-          <a:bodyPr rtlCol="0" anchor="t" wrap="square" lIns="109728" rIns="109728" tIns="73152"/>
+          <a:bodyPr wrap="square" lIns="109728" tIns="73152" rIns="109728" rtlCol="0" anchor="t"/>
           <a:lstStyle/>
           <a:p>
             <a:pPr algn="l"/>
@@ -3443,7 +3445,7 @@
           </a:fontRef>
         </p:style>
         <p:txBody>
-          <a:bodyPr rtlCol="0" anchor="t" wrap="square" lIns="109728" rIns="109728" tIns="73152"/>
+          <a:bodyPr wrap="square" lIns="109728" tIns="73152" rIns="109728" rtlCol="0" anchor="t"/>
           <a:lstStyle/>
           <a:p>
             <a:pPr algn="l"/>
@@ -3524,7 +3526,7 @@
           </a:fontRef>
         </p:style>
         <p:txBody>
-          <a:bodyPr rtlCol="0" anchor="t" wrap="square" lIns="109728" rIns="109728" tIns="73152"/>
+          <a:bodyPr wrap="square" lIns="109728" tIns="73152" rIns="109728" rtlCol="0" anchor="t"/>
           <a:lstStyle/>
           <a:p>
             <a:pPr algn="l"/>
@@ -3605,7 +3607,7 @@
           </a:fontRef>
         </p:style>
         <p:txBody>
-          <a:bodyPr rtlCol="0" anchor="t" wrap="square" lIns="109728" rIns="109728" tIns="73152"/>
+          <a:bodyPr wrap="square" lIns="109728" tIns="73152" rIns="109728" rtlCol="0" anchor="t"/>
           <a:lstStyle/>
           <a:p>
             <a:pPr algn="l"/>
@@ -3698,7 +3700,7 @@
           </a:fontRef>
         </p:style>
         <p:txBody>
-          <a:bodyPr rtlCol="0" anchor="t" wrap="square" lIns="109728" rIns="109728" tIns="73152"/>
+          <a:bodyPr wrap="square" lIns="109728" tIns="73152" rIns="109728" rtlCol="0" anchor="t"/>
           <a:lstStyle/>
           <a:p>
             <a:pPr algn="l"/>
@@ -4224,7 +4226,7 @@
           </a:fontRef>
         </p:style>
         <p:txBody>
-          <a:bodyPr rtlCol="0" anchor="t" wrap="square" lIns="109728" rIns="109728" tIns="73152"/>
+          <a:bodyPr wrap="square" lIns="109728" tIns="73152" rIns="109728" rtlCol="0" anchor="t"/>
           <a:lstStyle/>
           <a:p>
             <a:pPr algn="l"/>
@@ -4305,7 +4307,7 @@
           </a:fontRef>
         </p:style>
         <p:txBody>
-          <a:bodyPr rtlCol="0" anchor="t" wrap="square" lIns="109728" rIns="109728" tIns="73152"/>
+          <a:bodyPr wrap="square" lIns="109728" tIns="73152" rIns="109728" rtlCol="0" anchor="t"/>
           <a:lstStyle/>
           <a:p>
             <a:pPr algn="l"/>
@@ -4388,7 +4390,7 @@
 </file>
 
 <file path=ppt/slides/slide2.xml><?xml version="1.0" encoding="utf-8"?>
-<p:sld xmlns:a="http://schemas.openxmlformats.org/drawingml/2006/main" xmlns:p="http://schemas.openxmlformats.org/presentationml/2006/main" xmlns:r="http://schemas.openxmlformats.org/officeDocument/2006/relationships">
+<p:sld xmlns:a="http://schemas.openxmlformats.org/drawingml/2006/main" xmlns:r="http://schemas.openxmlformats.org/officeDocument/2006/relationships" xmlns:p="http://schemas.openxmlformats.org/presentationml/2006/main">
   <p:cSld>
     <p:spTree>
       <p:nvGrpSpPr>
@@ -4396,7 +4398,14 @@
         <p:cNvGrpSpPr/>
         <p:nvPr/>
       </p:nvGrpSpPr>
-      <p:grpSpPr/>
+      <p:grpSpPr>
+        <a:xfrm>
+          <a:off x="0" y="0"/>
+          <a:ext cx="0" cy="0"/>
+          <a:chOff x="0" y="0"/>
+          <a:chExt cx="0" cy="0"/>
+        </a:xfrm>
+      </p:grpSpPr>
       <p:sp>
         <p:nvSpPr>
           <p:cNvPr id="2" name="TextBox 1"/>
@@ -4483,7 +4492,7 @@
           </a:fontRef>
         </p:style>
         <p:txBody>
-          <a:bodyPr rtlCol="0" anchor="t" wrap="square" lIns="109728" rIns="109728" tIns="73152"/>
+          <a:bodyPr wrap="square" lIns="109728" tIns="73152" rIns="109728" rtlCol="0" anchor="t"/>
           <a:lstStyle/>
           <a:p>
             <a:pPr algn="l"/>
@@ -4564,7 +4573,7 @@
           </a:fontRef>
         </p:style>
         <p:txBody>
-          <a:bodyPr rtlCol="0" anchor="t" wrap="square" lIns="109728" rIns="109728" tIns="73152"/>
+          <a:bodyPr wrap="square" lIns="109728" tIns="73152" rIns="109728" rtlCol="0" anchor="t"/>
           <a:lstStyle/>
           <a:p>
             <a:pPr algn="l"/>
@@ -4645,7 +4654,7 @@
           </a:fontRef>
         </p:style>
         <p:txBody>
-          <a:bodyPr rtlCol="0" anchor="t" wrap="square" lIns="109728" rIns="109728" tIns="73152"/>
+          <a:bodyPr wrap="square" lIns="109728" tIns="73152" rIns="109728" rtlCol="0" anchor="t"/>
           <a:lstStyle/>
           <a:p>
             <a:pPr algn="l"/>
@@ -4726,7 +4735,7 @@
           </a:fontRef>
         </p:style>
         <p:txBody>
-          <a:bodyPr rtlCol="0" anchor="t" wrap="square" lIns="109728" rIns="109728" tIns="73152"/>
+          <a:bodyPr wrap="square" lIns="109728" tIns="73152" rIns="109728" rtlCol="0" anchor="t"/>
           <a:lstStyle/>
           <a:p>
             <a:pPr algn="l"/>
@@ -4807,7 +4816,7 @@
           </a:fontRef>
         </p:style>
         <p:txBody>
-          <a:bodyPr rtlCol="0" anchor="t" wrap="square" lIns="109728" rIns="109728" tIns="73152"/>
+          <a:bodyPr wrap="square" lIns="109728" tIns="73152" rIns="109728" rtlCol="0" anchor="t"/>
           <a:lstStyle/>
           <a:p>
             <a:pPr algn="l"/>
@@ -4888,7 +4897,7 @@
           </a:fontRef>
         </p:style>
         <p:txBody>
-          <a:bodyPr rtlCol="0" anchor="t" wrap="square" lIns="109728" rIns="109728" tIns="73152"/>
+          <a:bodyPr wrap="square" lIns="109728" tIns="73152" rIns="109728" rtlCol="0" anchor="t"/>
           <a:lstStyle/>
           <a:p>
             <a:pPr algn="l"/>
@@ -5236,7 +5245,7 @@
 </file>
 
 <file path=ppt/slides/slide3.xml><?xml version="1.0" encoding="utf-8"?>
-<p:sld xmlns:a="http://schemas.openxmlformats.org/drawingml/2006/main" xmlns:p="http://schemas.openxmlformats.org/presentationml/2006/main" xmlns:r="http://schemas.openxmlformats.org/officeDocument/2006/relationships">
+<p:sld xmlns:a="http://schemas.openxmlformats.org/drawingml/2006/main" xmlns:r="http://schemas.openxmlformats.org/officeDocument/2006/relationships" xmlns:p="http://schemas.openxmlformats.org/presentationml/2006/main">
   <p:cSld>
     <p:spTree>
       <p:nvGrpSpPr>
@@ -5244,7 +5253,14 @@
         <p:cNvGrpSpPr/>
         <p:nvPr/>
       </p:nvGrpSpPr>
-      <p:grpSpPr/>
+      <p:grpSpPr>
+        <a:xfrm>
+          <a:off x="0" y="0"/>
+          <a:ext cx="0" cy="0"/>
+          <a:chOff x="0" y="0"/>
+          <a:chExt cx="0" cy="0"/>
+        </a:xfrm>
+      </p:grpSpPr>
       <p:sp>
         <p:nvSpPr>
           <p:cNvPr id="2" name="TextBox 1"/>
@@ -5329,7 +5345,7 @@
           </a:fontRef>
         </p:style>
         <p:txBody>
-          <a:bodyPr rtlCol="0" anchor="t" wrap="square" lIns="109728" rIns="109728" tIns="73152"/>
+          <a:bodyPr wrap="square" lIns="109728" tIns="73152" rIns="109728" rtlCol="0" anchor="t"/>
           <a:lstStyle/>
           <a:p>
             <a:pPr algn="l"/>
@@ -5396,7 +5412,7 @@
           </a:fontRef>
         </p:style>
         <p:txBody>
-          <a:bodyPr rtlCol="0" anchor="t" wrap="square" lIns="109728" rIns="109728" tIns="73152"/>
+          <a:bodyPr wrap="square" lIns="109728" tIns="73152" rIns="109728" rtlCol="0" anchor="t"/>
           <a:lstStyle/>
           <a:p>
             <a:pPr algn="l"/>
@@ -5463,7 +5479,7 @@
           </a:fontRef>
         </p:style>
         <p:txBody>
-          <a:bodyPr rtlCol="0" anchor="t" wrap="square" lIns="109728" rIns="109728" tIns="73152"/>
+          <a:bodyPr wrap="square" lIns="109728" tIns="73152" rIns="109728" rtlCol="0" anchor="t"/>
           <a:lstStyle/>
           <a:p>
             <a:pPr algn="l"/>
@@ -5530,7 +5546,7 @@
           </a:fontRef>
         </p:style>
         <p:txBody>
-          <a:bodyPr rtlCol="0" anchor="t" wrap="square" lIns="109728" rIns="109728" tIns="73152"/>
+          <a:bodyPr wrap="square" lIns="109728" tIns="73152" rIns="109728" rtlCol="0" anchor="t"/>
           <a:lstStyle/>
           <a:p>
             <a:pPr algn="l"/>

</xml_diff>

<commit_message>
docs: corrige incongruencias de la primera parte (trazabilidad, protección de ramas, revisión del PR y jobs en rojo)
</commit_message>
<xml_diff>
--- a/docs/Diagramas - Actividad 2.pptx
+++ b/docs/Diagramas - Actividad 2.pptx
@@ -5,11 +5,11 @@
     <p:sldMasterId id="2147483648" r:id="rId1"/>
   </p:sldMasterIdLst>
   <p:sldIdLst>
-    <p:sldId id="256" r:id="rId2"/>
-    <p:sldId id="257" r:id="rId3"/>
-    <p:sldId id="258" r:id="rId4"/>
+    <p:sldId id="256" r:id="rId7"/>
+    <p:sldId id="257" r:id="rId8"/>
+    <p:sldId id="258" r:id="rId9"/>
   </p:sldIdLst>
-  <p:sldSz cx="12192000" cy="6858000"/>
+  <p:sldSz cx="12191695" cy="6858000" type="screen4x3"/>
   <p:notesSz cx="6858000" cy="9144000"/>
   <p:defaultTextStyle>
     <a:defPPr>
@@ -106,22 +106,6 @@
       </a:defRPr>
     </a:lvl9pPr>
   </p:defaultTextStyle>
-  <p:extLst>
-    <p:ext uri="{EFAFB233-063F-42B5-8137-9DF3F51BA10A}">
-      <p15:sldGuideLst xmlns:p15="http://schemas.microsoft.com/office/powerpoint/2012/main">
-        <p15:guide id="1" orient="horz" pos="2160">
-          <p15:clr>
-            <a:srgbClr val="A4A3A4"/>
-          </p15:clr>
-        </p15:guide>
-        <p15:guide id="2" pos="2880">
-          <p15:clr>
-            <a:srgbClr val="A4A3A4"/>
-          </p15:clr>
-        </p15:guide>
-      </p15:sldGuideLst>
-    </p:ext>
-  </p:extLst>
 </p:presentation>
 </file>
 
@@ -163,9 +147,10 @@
           <a:lstStyle/>
           <a:p>
             <a:r>
-              <a:rPr lang="en-US"/>
+              <a:rPr lang="en-US" smtClean="0"/>
               <a:t>Click to edit Master title style</a:t>
             </a:r>
+            <a:endParaRPr lang="en-US"/>
           </a:p>
         </p:txBody>
       </p:sp>
@@ -281,9 +266,10 @@
           </a:lstStyle>
           <a:p>
             <a:r>
-              <a:rPr lang="en-US"/>
+              <a:rPr lang="en-US" smtClean="0"/>
               <a:t>Click to edit Master subtitle style</a:t>
             </a:r>
+            <a:endParaRPr lang="en-US"/>
           </a:p>
         </p:txBody>
       </p:sp>
@@ -304,7 +290,7 @@
           <a:p>
             <a:fld id="{5BCAD085-E8A6-8845-BD4E-CB4CCA059FC4}" type="datetimeFigureOut">
               <a:rPr lang="en-US" smtClean="0"/>
-              <a:t>10/28/2026</a:t>
+              <a:t>1/27/13</a:t>
             </a:fld>
             <a:endParaRPr lang="en-US"/>
           </a:p>
@@ -346,7 +332,7 @@
           <a:p>
             <a:fld id="{C1FF6DA9-008F-8B48-92A6-B652298478BF}" type="slidenum">
               <a:rPr lang="en-US" smtClean="0"/>
-              <a:t>‹Nº›</a:t>
+              <a:t>‹#›</a:t>
             </a:fld>
             <a:endParaRPr lang="en-US"/>
           </a:p>
@@ -398,9 +384,10 @@
           <a:lstStyle/>
           <a:p>
             <a:r>
-              <a:rPr lang="en-US"/>
+              <a:rPr lang="en-US" smtClean="0"/>
               <a:t>Click to edit Master title style</a:t>
             </a:r>
+            <a:endParaRPr lang="en-US"/>
           </a:p>
         </p:txBody>
       </p:sp>
@@ -421,37 +408,38 @@
           <a:p>
             <a:pPr lvl="0"/>
             <a:r>
-              <a:rPr lang="en-US"/>
+              <a:rPr lang="en-US" smtClean="0"/>
               <a:t>Click to edit Master text styles</a:t>
             </a:r>
           </a:p>
           <a:p>
             <a:pPr lvl="1"/>
             <a:r>
-              <a:rPr lang="en-US"/>
+              <a:rPr lang="en-US" smtClean="0"/>
               <a:t>Second level</a:t>
             </a:r>
           </a:p>
           <a:p>
             <a:pPr lvl="2"/>
             <a:r>
-              <a:rPr lang="en-US"/>
+              <a:rPr lang="en-US" smtClean="0"/>
               <a:t>Third level</a:t>
             </a:r>
           </a:p>
           <a:p>
             <a:pPr lvl="3"/>
             <a:r>
-              <a:rPr lang="en-US"/>
+              <a:rPr lang="en-US" smtClean="0"/>
               <a:t>Fourth level</a:t>
             </a:r>
           </a:p>
           <a:p>
             <a:pPr lvl="4"/>
             <a:r>
-              <a:rPr lang="en-US"/>
+              <a:rPr lang="en-US" smtClean="0"/>
               <a:t>Fifth level</a:t>
             </a:r>
+            <a:endParaRPr lang="en-US"/>
           </a:p>
         </p:txBody>
       </p:sp>
@@ -472,7 +460,7 @@
           <a:p>
             <a:fld id="{5BCAD085-E8A6-8845-BD4E-CB4CCA059FC4}" type="datetimeFigureOut">
               <a:rPr lang="en-US" smtClean="0"/>
-              <a:t>10/28/2026</a:t>
+              <a:t>1/27/13</a:t>
             </a:fld>
             <a:endParaRPr lang="en-US"/>
           </a:p>
@@ -514,7 +502,7 @@
           <a:p>
             <a:fld id="{C1FF6DA9-008F-8B48-92A6-B652298478BF}" type="slidenum">
               <a:rPr lang="en-US" smtClean="0"/>
-              <a:t>‹Nº›</a:t>
+              <a:t>‹#›</a:t>
             </a:fld>
             <a:endParaRPr lang="en-US"/>
           </a:p>
@@ -571,9 +559,10 @@
           <a:lstStyle/>
           <a:p>
             <a:r>
-              <a:rPr lang="en-US"/>
+              <a:rPr lang="en-US" smtClean="0"/>
               <a:t>Click to edit Master title style</a:t>
             </a:r>
+            <a:endParaRPr lang="en-US"/>
           </a:p>
         </p:txBody>
       </p:sp>
@@ -599,37 +588,38 @@
           <a:p>
             <a:pPr lvl="0"/>
             <a:r>
-              <a:rPr lang="en-US"/>
+              <a:rPr lang="en-US" smtClean="0"/>
               <a:t>Click to edit Master text styles</a:t>
             </a:r>
           </a:p>
           <a:p>
             <a:pPr lvl="1"/>
             <a:r>
-              <a:rPr lang="en-US"/>
+              <a:rPr lang="en-US" smtClean="0"/>
               <a:t>Second level</a:t>
             </a:r>
           </a:p>
           <a:p>
             <a:pPr lvl="2"/>
             <a:r>
-              <a:rPr lang="en-US"/>
+              <a:rPr lang="en-US" smtClean="0"/>
               <a:t>Third level</a:t>
             </a:r>
           </a:p>
           <a:p>
             <a:pPr lvl="3"/>
             <a:r>
-              <a:rPr lang="en-US"/>
+              <a:rPr lang="en-US" smtClean="0"/>
               <a:t>Fourth level</a:t>
             </a:r>
           </a:p>
           <a:p>
             <a:pPr lvl="4"/>
             <a:r>
-              <a:rPr lang="en-US"/>
+              <a:rPr lang="en-US" smtClean="0"/>
               <a:t>Fifth level</a:t>
             </a:r>
+            <a:endParaRPr lang="en-US"/>
           </a:p>
         </p:txBody>
       </p:sp>
@@ -650,7 +640,7 @@
           <a:p>
             <a:fld id="{5BCAD085-E8A6-8845-BD4E-CB4CCA059FC4}" type="datetimeFigureOut">
               <a:rPr lang="en-US" smtClean="0"/>
-              <a:t>10/28/2026</a:t>
+              <a:t>1/27/13</a:t>
             </a:fld>
             <a:endParaRPr lang="en-US"/>
           </a:p>
@@ -692,7 +682,7 @@
           <a:p>
             <a:fld id="{C1FF6DA9-008F-8B48-92A6-B652298478BF}" type="slidenum">
               <a:rPr lang="en-US" smtClean="0"/>
-              <a:t>‹Nº›</a:t>
+              <a:t>‹#›</a:t>
             </a:fld>
             <a:endParaRPr lang="en-US"/>
           </a:p>
@@ -744,9 +734,10 @@
           <a:lstStyle/>
           <a:p>
             <a:r>
-              <a:rPr lang="en-US"/>
+              <a:rPr lang="en-US" smtClean="0"/>
               <a:t>Click to edit Master title style</a:t>
             </a:r>
+            <a:endParaRPr lang="en-US"/>
           </a:p>
         </p:txBody>
       </p:sp>
@@ -767,37 +758,38 @@
           <a:p>
             <a:pPr lvl="0"/>
             <a:r>
-              <a:rPr lang="en-US"/>
+              <a:rPr lang="en-US" smtClean="0"/>
               <a:t>Click to edit Master text styles</a:t>
             </a:r>
           </a:p>
           <a:p>
             <a:pPr lvl="1"/>
             <a:r>
-              <a:rPr lang="en-US"/>
+              <a:rPr lang="en-US" smtClean="0"/>
               <a:t>Second level</a:t>
             </a:r>
           </a:p>
           <a:p>
             <a:pPr lvl="2"/>
             <a:r>
-              <a:rPr lang="en-US"/>
+              <a:rPr lang="en-US" smtClean="0"/>
               <a:t>Third level</a:t>
             </a:r>
           </a:p>
           <a:p>
             <a:pPr lvl="3"/>
             <a:r>
-              <a:rPr lang="en-US"/>
+              <a:rPr lang="en-US" smtClean="0"/>
               <a:t>Fourth level</a:t>
             </a:r>
           </a:p>
           <a:p>
             <a:pPr lvl="4"/>
             <a:r>
-              <a:rPr lang="en-US"/>
+              <a:rPr lang="en-US" smtClean="0"/>
               <a:t>Fifth level</a:t>
             </a:r>
+            <a:endParaRPr lang="en-US"/>
           </a:p>
         </p:txBody>
       </p:sp>
@@ -818,7 +810,7 @@
           <a:p>
             <a:fld id="{5BCAD085-E8A6-8845-BD4E-CB4CCA059FC4}" type="datetimeFigureOut">
               <a:rPr lang="en-US" smtClean="0"/>
-              <a:t>10/28/2026</a:t>
+              <a:t>1/27/13</a:t>
             </a:fld>
             <a:endParaRPr lang="en-US"/>
           </a:p>
@@ -860,7 +852,7 @@
           <a:p>
             <a:fld id="{C1FF6DA9-008F-8B48-92A6-B652298478BF}" type="slidenum">
               <a:rPr lang="en-US" smtClean="0"/>
-              <a:t>‹Nº›</a:t>
+              <a:t>‹#›</a:t>
             </a:fld>
             <a:endParaRPr lang="en-US"/>
           </a:p>
@@ -921,9 +913,10 @@
           </a:lstStyle>
           <a:p>
             <a:r>
-              <a:rPr lang="en-US"/>
+              <a:rPr lang="en-US" smtClean="0"/>
               <a:t>Click to edit Master title style</a:t>
             </a:r>
+            <a:endParaRPr lang="en-US"/>
           </a:p>
         </p:txBody>
       </p:sp>
@@ -1040,7 +1033,7 @@
           <a:p>
             <a:pPr lvl="0"/>
             <a:r>
-              <a:rPr lang="en-US"/>
+              <a:rPr lang="en-US" smtClean="0"/>
               <a:t>Click to edit Master text styles</a:t>
             </a:r>
           </a:p>
@@ -1063,7 +1056,7 @@
           <a:p>
             <a:fld id="{5BCAD085-E8A6-8845-BD4E-CB4CCA059FC4}" type="datetimeFigureOut">
               <a:rPr lang="en-US" smtClean="0"/>
-              <a:t>10/28/2026</a:t>
+              <a:t>1/27/13</a:t>
             </a:fld>
             <a:endParaRPr lang="en-US"/>
           </a:p>
@@ -1105,7 +1098,7 @@
           <a:p>
             <a:fld id="{C1FF6DA9-008F-8B48-92A6-B652298478BF}" type="slidenum">
               <a:rPr lang="en-US" smtClean="0"/>
-              <a:t>‹Nº›</a:t>
+              <a:t>‹#›</a:t>
             </a:fld>
             <a:endParaRPr lang="en-US"/>
           </a:p>
@@ -1157,9 +1150,10 @@
           <a:lstStyle/>
           <a:p>
             <a:r>
-              <a:rPr lang="en-US"/>
+              <a:rPr lang="en-US" smtClean="0"/>
               <a:t>Click to edit Master title style</a:t>
             </a:r>
+            <a:endParaRPr lang="en-US"/>
           </a:p>
         </p:txBody>
       </p:sp>
@@ -1213,37 +1207,38 @@
           <a:p>
             <a:pPr lvl="0"/>
             <a:r>
-              <a:rPr lang="en-US"/>
+              <a:rPr lang="en-US" smtClean="0"/>
               <a:t>Click to edit Master text styles</a:t>
             </a:r>
           </a:p>
           <a:p>
             <a:pPr lvl="1"/>
             <a:r>
-              <a:rPr lang="en-US"/>
+              <a:rPr lang="en-US" smtClean="0"/>
               <a:t>Second level</a:t>
             </a:r>
           </a:p>
           <a:p>
             <a:pPr lvl="2"/>
             <a:r>
-              <a:rPr lang="en-US"/>
+              <a:rPr lang="en-US" smtClean="0"/>
               <a:t>Third level</a:t>
             </a:r>
           </a:p>
           <a:p>
             <a:pPr lvl="3"/>
             <a:r>
-              <a:rPr lang="en-US"/>
+              <a:rPr lang="en-US" smtClean="0"/>
               <a:t>Fourth level</a:t>
             </a:r>
           </a:p>
           <a:p>
             <a:pPr lvl="4"/>
             <a:r>
-              <a:rPr lang="en-US"/>
+              <a:rPr lang="en-US" smtClean="0"/>
               <a:t>Fifth level</a:t>
             </a:r>
+            <a:endParaRPr lang="en-US"/>
           </a:p>
         </p:txBody>
       </p:sp>
@@ -1297,37 +1292,38 @@
           <a:p>
             <a:pPr lvl="0"/>
             <a:r>
-              <a:rPr lang="en-US"/>
+              <a:rPr lang="en-US" smtClean="0"/>
               <a:t>Click to edit Master text styles</a:t>
             </a:r>
           </a:p>
           <a:p>
             <a:pPr lvl="1"/>
             <a:r>
-              <a:rPr lang="en-US"/>
+              <a:rPr lang="en-US" smtClean="0"/>
               <a:t>Second level</a:t>
             </a:r>
           </a:p>
           <a:p>
             <a:pPr lvl="2"/>
             <a:r>
-              <a:rPr lang="en-US"/>
+              <a:rPr lang="en-US" smtClean="0"/>
               <a:t>Third level</a:t>
             </a:r>
           </a:p>
           <a:p>
             <a:pPr lvl="3"/>
             <a:r>
-              <a:rPr lang="en-US"/>
+              <a:rPr lang="en-US" smtClean="0"/>
               <a:t>Fourth level</a:t>
             </a:r>
           </a:p>
           <a:p>
             <a:pPr lvl="4"/>
             <a:r>
-              <a:rPr lang="en-US"/>
+              <a:rPr lang="en-US" smtClean="0"/>
               <a:t>Fifth level</a:t>
             </a:r>
+            <a:endParaRPr lang="en-US"/>
           </a:p>
         </p:txBody>
       </p:sp>
@@ -1348,7 +1344,7 @@
           <a:p>
             <a:fld id="{5BCAD085-E8A6-8845-BD4E-CB4CCA059FC4}" type="datetimeFigureOut">
               <a:rPr lang="en-US" smtClean="0"/>
-              <a:t>10/28/2026</a:t>
+              <a:t>1/27/13</a:t>
             </a:fld>
             <a:endParaRPr lang="en-US"/>
           </a:p>
@@ -1390,7 +1386,7 @@
           <a:p>
             <a:fld id="{C1FF6DA9-008F-8B48-92A6-B652298478BF}" type="slidenum">
               <a:rPr lang="en-US" smtClean="0"/>
-              <a:t>‹Nº›</a:t>
+              <a:t>‹#›</a:t>
             </a:fld>
             <a:endParaRPr lang="en-US"/>
           </a:p>
@@ -1446,9 +1442,10 @@
           </a:lstStyle>
           <a:p>
             <a:r>
-              <a:rPr lang="en-US"/>
+              <a:rPr lang="en-US" smtClean="0"/>
               <a:t>Click to edit Master title style</a:t>
             </a:r>
+            <a:endParaRPr lang="en-US"/>
           </a:p>
         </p:txBody>
       </p:sp>
@@ -1511,7 +1508,7 @@
           <a:p>
             <a:pPr lvl="0"/>
             <a:r>
-              <a:rPr lang="en-US"/>
+              <a:rPr lang="en-US" smtClean="0"/>
               <a:t>Click to edit Master text styles</a:t>
             </a:r>
           </a:p>
@@ -1567,37 +1564,38 @@
           <a:p>
             <a:pPr lvl="0"/>
             <a:r>
-              <a:rPr lang="en-US"/>
+              <a:rPr lang="en-US" smtClean="0"/>
               <a:t>Click to edit Master text styles</a:t>
             </a:r>
           </a:p>
           <a:p>
             <a:pPr lvl="1"/>
             <a:r>
-              <a:rPr lang="en-US"/>
+              <a:rPr lang="en-US" smtClean="0"/>
               <a:t>Second level</a:t>
             </a:r>
           </a:p>
           <a:p>
             <a:pPr lvl="2"/>
             <a:r>
-              <a:rPr lang="en-US"/>
+              <a:rPr lang="en-US" smtClean="0"/>
               <a:t>Third level</a:t>
             </a:r>
           </a:p>
           <a:p>
             <a:pPr lvl="3"/>
             <a:r>
-              <a:rPr lang="en-US"/>
+              <a:rPr lang="en-US" smtClean="0"/>
               <a:t>Fourth level</a:t>
             </a:r>
           </a:p>
           <a:p>
             <a:pPr lvl="4"/>
             <a:r>
-              <a:rPr lang="en-US"/>
+              <a:rPr lang="en-US" smtClean="0"/>
               <a:t>Fifth level</a:t>
             </a:r>
+            <a:endParaRPr lang="en-US"/>
           </a:p>
         </p:txBody>
       </p:sp>
@@ -1660,7 +1658,7 @@
           <a:p>
             <a:pPr lvl="0"/>
             <a:r>
-              <a:rPr lang="en-US"/>
+              <a:rPr lang="en-US" smtClean="0"/>
               <a:t>Click to edit Master text styles</a:t>
             </a:r>
           </a:p>
@@ -1716,37 +1714,38 @@
           <a:p>
             <a:pPr lvl="0"/>
             <a:r>
-              <a:rPr lang="en-US"/>
+              <a:rPr lang="en-US" smtClean="0"/>
               <a:t>Click to edit Master text styles</a:t>
             </a:r>
           </a:p>
           <a:p>
             <a:pPr lvl="1"/>
             <a:r>
-              <a:rPr lang="en-US"/>
+              <a:rPr lang="en-US" smtClean="0"/>
               <a:t>Second level</a:t>
             </a:r>
           </a:p>
           <a:p>
             <a:pPr lvl="2"/>
             <a:r>
-              <a:rPr lang="en-US"/>
+              <a:rPr lang="en-US" smtClean="0"/>
               <a:t>Third level</a:t>
             </a:r>
           </a:p>
           <a:p>
             <a:pPr lvl="3"/>
             <a:r>
-              <a:rPr lang="en-US"/>
+              <a:rPr lang="en-US" smtClean="0"/>
               <a:t>Fourth level</a:t>
             </a:r>
           </a:p>
           <a:p>
             <a:pPr lvl="4"/>
             <a:r>
-              <a:rPr lang="en-US"/>
+              <a:rPr lang="en-US" smtClean="0"/>
               <a:t>Fifth level</a:t>
             </a:r>
+            <a:endParaRPr lang="en-US"/>
           </a:p>
         </p:txBody>
       </p:sp>
@@ -1767,7 +1766,7 @@
           <a:p>
             <a:fld id="{5BCAD085-E8A6-8845-BD4E-CB4CCA059FC4}" type="datetimeFigureOut">
               <a:rPr lang="en-US" smtClean="0"/>
-              <a:t>10/28/2026</a:t>
+              <a:t>1/27/13</a:t>
             </a:fld>
             <a:endParaRPr lang="en-US"/>
           </a:p>
@@ -1809,7 +1808,7 @@
           <a:p>
             <a:fld id="{C1FF6DA9-008F-8B48-92A6-B652298478BF}" type="slidenum">
               <a:rPr lang="en-US" smtClean="0"/>
-              <a:t>‹Nº›</a:t>
+              <a:t>‹#›</a:t>
             </a:fld>
             <a:endParaRPr lang="en-US"/>
           </a:p>
@@ -1861,9 +1860,10 @@
           <a:lstStyle/>
           <a:p>
             <a:r>
-              <a:rPr lang="en-US"/>
+              <a:rPr lang="en-US" smtClean="0"/>
               <a:t>Click to edit Master title style</a:t>
             </a:r>
+            <a:endParaRPr lang="en-US"/>
           </a:p>
         </p:txBody>
       </p:sp>
@@ -1884,7 +1884,7 @@
           <a:p>
             <a:fld id="{5BCAD085-E8A6-8845-BD4E-CB4CCA059FC4}" type="datetimeFigureOut">
               <a:rPr lang="en-US" smtClean="0"/>
-              <a:t>10/28/2026</a:t>
+              <a:t>1/27/13</a:t>
             </a:fld>
             <a:endParaRPr lang="en-US"/>
           </a:p>
@@ -1926,7 +1926,7 @@
           <a:p>
             <a:fld id="{C1FF6DA9-008F-8B48-92A6-B652298478BF}" type="slidenum">
               <a:rPr lang="en-US" smtClean="0"/>
-              <a:t>‹Nº›</a:t>
+              <a:t>‹#›</a:t>
             </a:fld>
             <a:endParaRPr lang="en-US"/>
           </a:p>
@@ -1979,7 +1979,7 @@
           <a:p>
             <a:fld id="{5BCAD085-E8A6-8845-BD4E-CB4CCA059FC4}" type="datetimeFigureOut">
               <a:rPr lang="en-US" smtClean="0"/>
-              <a:t>10/28/2026</a:t>
+              <a:t>1/27/13</a:t>
             </a:fld>
             <a:endParaRPr lang="en-US"/>
           </a:p>
@@ -2021,7 +2021,7 @@
           <a:p>
             <a:fld id="{C1FF6DA9-008F-8B48-92A6-B652298478BF}" type="slidenum">
               <a:rPr lang="en-US" smtClean="0"/>
-              <a:t>‹Nº›</a:t>
+              <a:t>‹#›</a:t>
             </a:fld>
             <a:endParaRPr lang="en-US"/>
           </a:p>
@@ -2082,9 +2082,10 @@
           </a:lstStyle>
           <a:p>
             <a:r>
-              <a:rPr lang="en-US"/>
+              <a:rPr lang="en-US" smtClean="0"/>
               <a:t>Click to edit Master title style</a:t>
             </a:r>
+            <a:endParaRPr lang="en-US"/>
           </a:p>
         </p:txBody>
       </p:sp>
@@ -2138,37 +2139,38 @@
           <a:p>
             <a:pPr lvl="0"/>
             <a:r>
-              <a:rPr lang="en-US"/>
+              <a:rPr lang="en-US" smtClean="0"/>
               <a:t>Click to edit Master text styles</a:t>
             </a:r>
           </a:p>
           <a:p>
             <a:pPr lvl="1"/>
             <a:r>
-              <a:rPr lang="en-US"/>
+              <a:rPr lang="en-US" smtClean="0"/>
               <a:t>Second level</a:t>
             </a:r>
           </a:p>
           <a:p>
             <a:pPr lvl="2"/>
             <a:r>
-              <a:rPr lang="en-US"/>
+              <a:rPr lang="en-US" smtClean="0"/>
               <a:t>Third level</a:t>
             </a:r>
           </a:p>
           <a:p>
             <a:pPr lvl="3"/>
             <a:r>
-              <a:rPr lang="en-US"/>
+              <a:rPr lang="en-US" smtClean="0"/>
               <a:t>Fourth level</a:t>
             </a:r>
           </a:p>
           <a:p>
             <a:pPr lvl="4"/>
             <a:r>
-              <a:rPr lang="en-US"/>
+              <a:rPr lang="en-US" smtClean="0"/>
               <a:t>Fifth level</a:t>
             </a:r>
+            <a:endParaRPr lang="en-US"/>
           </a:p>
         </p:txBody>
       </p:sp>
@@ -2231,7 +2233,7 @@
           <a:p>
             <a:pPr lvl="0"/>
             <a:r>
-              <a:rPr lang="en-US"/>
+              <a:rPr lang="en-US" smtClean="0"/>
               <a:t>Click to edit Master text styles</a:t>
             </a:r>
           </a:p>
@@ -2254,7 +2256,7 @@
           <a:p>
             <a:fld id="{5BCAD085-E8A6-8845-BD4E-CB4CCA059FC4}" type="datetimeFigureOut">
               <a:rPr lang="en-US" smtClean="0"/>
-              <a:t>10/28/2026</a:t>
+              <a:t>1/27/13</a:t>
             </a:fld>
             <a:endParaRPr lang="en-US"/>
           </a:p>
@@ -2296,7 +2298,7 @@
           <a:p>
             <a:fld id="{C1FF6DA9-008F-8B48-92A6-B652298478BF}" type="slidenum">
               <a:rPr lang="en-US" smtClean="0"/>
-              <a:t>‹Nº›</a:t>
+              <a:t>‹#›</a:t>
             </a:fld>
             <a:endParaRPr lang="en-US"/>
           </a:p>
@@ -2357,9 +2359,10 @@
           </a:lstStyle>
           <a:p>
             <a:r>
-              <a:rPr lang="en-US"/>
+              <a:rPr lang="en-US" smtClean="0"/>
               <a:t>Click to edit Master title style</a:t>
             </a:r>
+            <a:endParaRPr lang="en-US"/>
           </a:p>
         </p:txBody>
       </p:sp>
@@ -2483,7 +2486,7 @@
           <a:p>
             <a:pPr lvl="0"/>
             <a:r>
-              <a:rPr lang="en-US"/>
+              <a:rPr lang="en-US" smtClean="0"/>
               <a:t>Click to edit Master text styles</a:t>
             </a:r>
           </a:p>
@@ -2506,7 +2509,7 @@
           <a:p>
             <a:fld id="{5BCAD085-E8A6-8845-BD4E-CB4CCA059FC4}" type="datetimeFigureOut">
               <a:rPr lang="en-US" smtClean="0"/>
-              <a:t>10/28/2026</a:t>
+              <a:t>1/27/13</a:t>
             </a:fld>
             <a:endParaRPr lang="en-US"/>
           </a:p>
@@ -2548,7 +2551,7 @@
           <a:p>
             <a:fld id="{C1FF6DA9-008F-8B48-92A6-B652298478BF}" type="slidenum">
               <a:rPr lang="en-US" smtClean="0"/>
-              <a:t>‹Nº›</a:t>
+              <a:t>‹#›</a:t>
             </a:fld>
             <a:endParaRPr lang="en-US"/>
           </a:p>
@@ -2615,9 +2618,10 @@
           <a:lstStyle/>
           <a:p>
             <a:r>
-              <a:rPr lang="en-US"/>
+              <a:rPr lang="en-US" smtClean="0"/>
               <a:t>Click to edit Master title style</a:t>
             </a:r>
+            <a:endParaRPr lang="en-US"/>
           </a:p>
         </p:txBody>
       </p:sp>
@@ -2648,37 +2652,38 @@
           <a:p>
             <a:pPr lvl="0"/>
             <a:r>
-              <a:rPr lang="en-US"/>
+              <a:rPr lang="en-US" smtClean="0"/>
               <a:t>Click to edit Master text styles</a:t>
             </a:r>
           </a:p>
           <a:p>
             <a:pPr lvl="1"/>
             <a:r>
-              <a:rPr lang="en-US"/>
+              <a:rPr lang="en-US" smtClean="0"/>
               <a:t>Second level</a:t>
             </a:r>
           </a:p>
           <a:p>
             <a:pPr lvl="2"/>
             <a:r>
-              <a:rPr lang="en-US"/>
+              <a:rPr lang="en-US" smtClean="0"/>
               <a:t>Third level</a:t>
             </a:r>
           </a:p>
           <a:p>
             <a:pPr lvl="3"/>
             <a:r>
-              <a:rPr lang="en-US"/>
+              <a:rPr lang="en-US" smtClean="0"/>
               <a:t>Fourth level</a:t>
             </a:r>
           </a:p>
           <a:p>
             <a:pPr lvl="4"/>
             <a:r>
-              <a:rPr lang="en-US"/>
+              <a:rPr lang="en-US" smtClean="0"/>
               <a:t>Fifth level</a:t>
             </a:r>
+            <a:endParaRPr lang="en-US"/>
           </a:p>
         </p:txBody>
       </p:sp>
@@ -2717,7 +2722,7 @@
           <a:p>
             <a:fld id="{5BCAD085-E8A6-8845-BD4E-CB4CCA059FC4}" type="datetimeFigureOut">
               <a:rPr lang="en-US" smtClean="0"/>
-              <a:t>10/28/2026</a:t>
+              <a:t>1/27/13</a:t>
             </a:fld>
             <a:endParaRPr lang="en-US"/>
           </a:p>
@@ -2795,7 +2800,7 @@
           <a:p>
             <a:fld id="{C1FF6DA9-008F-8B48-92A6-B652298478BF}" type="slidenum">
               <a:rPr lang="en-US" smtClean="0"/>
-              <a:t>‹Nº›</a:t>
+              <a:t>‹#›</a:t>
             </a:fld>
             <a:endParaRPr lang="en-US"/>
           </a:p>
@@ -3076,7 +3081,7 @@
 </file>
 
 <file path=ppt/slides/slide1.xml><?xml version="1.0" encoding="utf-8"?>
-<p:sld xmlns:a="http://schemas.openxmlformats.org/drawingml/2006/main" xmlns:r="http://schemas.openxmlformats.org/officeDocument/2006/relationships" xmlns:p="http://schemas.openxmlformats.org/presentationml/2006/main">
+<p:sld xmlns:a="http://schemas.openxmlformats.org/drawingml/2006/main" xmlns:p="http://schemas.openxmlformats.org/presentationml/2006/main" xmlns:r="http://schemas.openxmlformats.org/officeDocument/2006/relationships">
   <p:cSld>
     <p:spTree>
       <p:nvGrpSpPr>
@@ -3084,14 +3089,7 @@
         <p:cNvGrpSpPr/>
         <p:nvPr/>
       </p:nvGrpSpPr>
-      <p:grpSpPr>
-        <a:xfrm>
-          <a:off x="0" y="0"/>
-          <a:ext cx="0" cy="0"/>
-          <a:chOff x="0" y="0"/>
-          <a:chExt cx="0" cy="0"/>
-        </a:xfrm>
-      </p:grpSpPr>
+      <p:grpSpPr/>
       <p:sp>
         <p:nvSpPr>
           <p:cNvPr id="2" name="TextBox 1"/>
@@ -3178,7 +3176,7 @@
           </a:fontRef>
         </p:style>
         <p:txBody>
-          <a:bodyPr wrap="square" lIns="109728" tIns="73152" rIns="109728" rtlCol="0" anchor="t"/>
+          <a:bodyPr rtlCol="0" anchor="t" wrap="square" lIns="109728" rIns="109728" tIns="73152"/>
           <a:lstStyle/>
           <a:p>
             <a:pPr algn="l"/>
@@ -3283,7 +3281,7 @@
           </a:fontRef>
         </p:style>
         <p:txBody>
-          <a:bodyPr wrap="square" lIns="109728" tIns="73152" rIns="109728" rtlCol="0" anchor="t"/>
+          <a:bodyPr rtlCol="0" anchor="t" wrap="square" lIns="109728" rIns="109728" tIns="73152"/>
           <a:lstStyle/>
           <a:p>
             <a:pPr algn="l"/>
@@ -3364,7 +3362,7 @@
           </a:fontRef>
         </p:style>
         <p:txBody>
-          <a:bodyPr wrap="square" lIns="109728" tIns="73152" rIns="109728" rtlCol="0" anchor="t"/>
+          <a:bodyPr rtlCol="0" anchor="t" wrap="square" lIns="109728" rIns="109728" tIns="73152"/>
           <a:lstStyle/>
           <a:p>
             <a:pPr algn="l"/>
@@ -3445,7 +3443,7 @@
           </a:fontRef>
         </p:style>
         <p:txBody>
-          <a:bodyPr wrap="square" lIns="109728" tIns="73152" rIns="109728" rtlCol="0" anchor="t"/>
+          <a:bodyPr rtlCol="0" anchor="t" wrap="square" lIns="109728" rIns="109728" tIns="73152"/>
           <a:lstStyle/>
           <a:p>
             <a:pPr algn="l"/>
@@ -3526,7 +3524,7 @@
           </a:fontRef>
         </p:style>
         <p:txBody>
-          <a:bodyPr wrap="square" lIns="109728" tIns="73152" rIns="109728" rtlCol="0" anchor="t"/>
+          <a:bodyPr rtlCol="0" anchor="t" wrap="square" lIns="109728" rIns="109728" tIns="73152"/>
           <a:lstStyle/>
           <a:p>
             <a:pPr algn="l"/>
@@ -3607,7 +3605,7 @@
           </a:fontRef>
         </p:style>
         <p:txBody>
-          <a:bodyPr wrap="square" lIns="109728" tIns="73152" rIns="109728" rtlCol="0" anchor="t"/>
+          <a:bodyPr rtlCol="0" anchor="t" wrap="square" lIns="109728" rIns="109728" tIns="73152"/>
           <a:lstStyle/>
           <a:p>
             <a:pPr algn="l"/>
@@ -3700,7 +3698,7 @@
           </a:fontRef>
         </p:style>
         <p:txBody>
-          <a:bodyPr wrap="square" lIns="109728" tIns="73152" rIns="109728" rtlCol="0" anchor="t"/>
+          <a:bodyPr rtlCol="0" anchor="t" wrap="square" lIns="109728" rIns="109728" tIns="73152"/>
           <a:lstStyle/>
           <a:p>
             <a:pPr algn="l"/>
@@ -4226,7 +4224,7 @@
           </a:fontRef>
         </p:style>
         <p:txBody>
-          <a:bodyPr wrap="square" lIns="109728" tIns="73152" rIns="109728" rtlCol="0" anchor="t"/>
+          <a:bodyPr rtlCol="0" anchor="t" wrap="square" lIns="109728" rIns="109728" tIns="73152"/>
           <a:lstStyle/>
           <a:p>
             <a:pPr algn="l"/>
@@ -4307,7 +4305,7 @@
           </a:fontRef>
         </p:style>
         <p:txBody>
-          <a:bodyPr wrap="square" lIns="109728" tIns="73152" rIns="109728" rtlCol="0" anchor="t"/>
+          <a:bodyPr rtlCol="0" anchor="t" wrap="square" lIns="109728" rIns="109728" tIns="73152"/>
           <a:lstStyle/>
           <a:p>
             <a:pPr algn="l"/>
@@ -4390,7 +4388,7 @@
 </file>
 
 <file path=ppt/slides/slide2.xml><?xml version="1.0" encoding="utf-8"?>
-<p:sld xmlns:a="http://schemas.openxmlformats.org/drawingml/2006/main" xmlns:r="http://schemas.openxmlformats.org/officeDocument/2006/relationships" xmlns:p="http://schemas.openxmlformats.org/presentationml/2006/main">
+<p:sld xmlns:a="http://schemas.openxmlformats.org/drawingml/2006/main" xmlns:p="http://schemas.openxmlformats.org/presentationml/2006/main" xmlns:r="http://schemas.openxmlformats.org/officeDocument/2006/relationships">
   <p:cSld>
     <p:spTree>
       <p:nvGrpSpPr>
@@ -4398,14 +4396,7 @@
         <p:cNvGrpSpPr/>
         <p:nvPr/>
       </p:nvGrpSpPr>
-      <p:grpSpPr>
-        <a:xfrm>
-          <a:off x="0" y="0"/>
-          <a:ext cx="0" cy="0"/>
-          <a:chOff x="0" y="0"/>
-          <a:chExt cx="0" cy="0"/>
-        </a:xfrm>
-      </p:grpSpPr>
+      <p:grpSpPr/>
       <p:sp>
         <p:nvSpPr>
           <p:cNvPr id="2" name="TextBox 1"/>
@@ -4492,7 +4483,7 @@
           </a:fontRef>
         </p:style>
         <p:txBody>
-          <a:bodyPr wrap="square" lIns="109728" tIns="73152" rIns="109728" rtlCol="0" anchor="t"/>
+          <a:bodyPr rtlCol="0" anchor="t" wrap="square" lIns="109728" rIns="109728" tIns="73152"/>
           <a:lstStyle/>
           <a:p>
             <a:pPr algn="l"/>
@@ -4573,7 +4564,7 @@
           </a:fontRef>
         </p:style>
         <p:txBody>
-          <a:bodyPr wrap="square" lIns="109728" tIns="73152" rIns="109728" rtlCol="0" anchor="t"/>
+          <a:bodyPr rtlCol="0" anchor="t" wrap="square" lIns="109728" rIns="109728" tIns="73152"/>
           <a:lstStyle/>
           <a:p>
             <a:pPr algn="l"/>
@@ -4654,7 +4645,7 @@
           </a:fontRef>
         </p:style>
         <p:txBody>
-          <a:bodyPr wrap="square" lIns="109728" tIns="73152" rIns="109728" rtlCol="0" anchor="t"/>
+          <a:bodyPr rtlCol="0" anchor="t" wrap="square" lIns="109728" rIns="109728" tIns="73152"/>
           <a:lstStyle/>
           <a:p>
             <a:pPr algn="l"/>
@@ -4735,7 +4726,7 @@
           </a:fontRef>
         </p:style>
         <p:txBody>
-          <a:bodyPr wrap="square" lIns="109728" tIns="73152" rIns="109728" rtlCol="0" anchor="t"/>
+          <a:bodyPr rtlCol="0" anchor="t" wrap="square" lIns="109728" rIns="109728" tIns="73152"/>
           <a:lstStyle/>
           <a:p>
             <a:pPr algn="l"/>
@@ -4816,7 +4807,7 @@
           </a:fontRef>
         </p:style>
         <p:txBody>
-          <a:bodyPr wrap="square" lIns="109728" tIns="73152" rIns="109728" rtlCol="0" anchor="t"/>
+          <a:bodyPr rtlCol="0" anchor="t" wrap="square" lIns="109728" rIns="109728" tIns="73152"/>
           <a:lstStyle/>
           <a:p>
             <a:pPr algn="l"/>
@@ -4897,7 +4888,7 @@
           </a:fontRef>
         </p:style>
         <p:txBody>
-          <a:bodyPr wrap="square" lIns="109728" tIns="73152" rIns="109728" rtlCol="0" anchor="t"/>
+          <a:bodyPr rtlCol="0" anchor="t" wrap="square" lIns="109728" rIns="109728" tIns="73152"/>
           <a:lstStyle/>
           <a:p>
             <a:pPr algn="l"/>
@@ -4920,7 +4911,7 @@
                 </a:solidFill>
                 <a:latin typeface="Calibri"/>
               </a:rPr>
-              <a:t>Emily aprueba el PR, merge a develop</a:t>
+              <a:t>Emily revisa el PR, merge a develop</a:t>
             </a:r>
           </a:p>
           <a:p>
@@ -5245,7 +5236,7 @@
 </file>
 
 <file path=ppt/slides/slide3.xml><?xml version="1.0" encoding="utf-8"?>
-<p:sld xmlns:a="http://schemas.openxmlformats.org/drawingml/2006/main" xmlns:r="http://schemas.openxmlformats.org/officeDocument/2006/relationships" xmlns:p="http://schemas.openxmlformats.org/presentationml/2006/main">
+<p:sld xmlns:a="http://schemas.openxmlformats.org/drawingml/2006/main" xmlns:p="http://schemas.openxmlformats.org/presentationml/2006/main" xmlns:r="http://schemas.openxmlformats.org/officeDocument/2006/relationships">
   <p:cSld>
     <p:spTree>
       <p:nvGrpSpPr>
@@ -5253,14 +5244,7 @@
         <p:cNvGrpSpPr/>
         <p:nvPr/>
       </p:nvGrpSpPr>
-      <p:grpSpPr>
-        <a:xfrm>
-          <a:off x="0" y="0"/>
-          <a:ext cx="0" cy="0"/>
-          <a:chOff x="0" y="0"/>
-          <a:chExt cx="0" cy="0"/>
-        </a:xfrm>
-      </p:grpSpPr>
+      <p:grpSpPr/>
       <p:sp>
         <p:nvSpPr>
           <p:cNvPr id="2" name="TextBox 1"/>
@@ -5345,7 +5329,7 @@
           </a:fontRef>
         </p:style>
         <p:txBody>
-          <a:bodyPr wrap="square" lIns="109728" tIns="73152" rIns="109728" rtlCol="0" anchor="t"/>
+          <a:bodyPr rtlCol="0" anchor="t" wrap="square" lIns="109728" rIns="109728" tIns="73152"/>
           <a:lstStyle/>
           <a:p>
             <a:pPr algn="l"/>
@@ -5412,7 +5396,7 @@
           </a:fontRef>
         </p:style>
         <p:txBody>
-          <a:bodyPr wrap="square" lIns="109728" tIns="73152" rIns="109728" rtlCol="0" anchor="t"/>
+          <a:bodyPr rtlCol="0" anchor="t" wrap="square" lIns="109728" rIns="109728" tIns="73152"/>
           <a:lstStyle/>
           <a:p>
             <a:pPr algn="l"/>
@@ -5479,7 +5463,7 @@
           </a:fontRef>
         </p:style>
         <p:txBody>
-          <a:bodyPr wrap="square" lIns="109728" tIns="73152" rIns="109728" rtlCol="0" anchor="t"/>
+          <a:bodyPr rtlCol="0" anchor="t" wrap="square" lIns="109728" rIns="109728" tIns="73152"/>
           <a:lstStyle/>
           <a:p>
             <a:pPr algn="l"/>
@@ -5546,7 +5530,7 @@
           </a:fontRef>
         </p:style>
         <p:txBody>
-          <a:bodyPr wrap="square" lIns="109728" tIns="73152" rIns="109728" rtlCol="0" anchor="t"/>
+          <a:bodyPr rtlCol="0" anchor="t" wrap="square" lIns="109728" rIns="109728" tIns="73152"/>
           <a:lstStyle/>
           <a:p>
             <a:pPr algn="l"/>

</xml_diff>